<commit_message>
Reframe slide 3 as Business problem with replacing Certain as the primary ask
Co-Authored-By: Claude Opus 5.5 <noreply@anthropic.com>
Claude-Session: https://claude.ai/code/session_0161UfSgfoLg2WkzVi8freAH
</commit_message>
<xml_diff>
--- a/deck/previews/reworked-deck-preview.pptx
+++ b/deck/previews/reworked-deck-preview.pptx
@@ -135,7 +135,7 @@
   <p:extLst>
     <p:ext uri="{521415D9-36F7-43E2-AB2F-B90AF26B5E84}">
       <p14:sectionLst xmlns:p14="http://schemas.microsoft.com/office/powerpoint/2010/main">
-        <p14:section name="Introduction" id="{2bb70609-27ad-5698-f756-6a136e17b0f8}">
+        <p14:section name="Introduction" id="{b42d9d74-7b0d-9c34-483e-30b7b05379fb}">
           <p14:sldIdLst>
             <p14:sldId id="256"/>
             <p14:sldId id="257"/>
@@ -143,7 +143,7 @@
             <p14:sldId id="259"/>
           </p14:sldIdLst>
         </p14:section>
-        <p14:section name="The solution" id="{c0bea536-2c7b-0392-75ad-852f922a9aad}">
+        <p14:section name="The solution" id="{31b7262f-ec50-6005-9b52-83a1092186c9}">
           <p14:sldIdLst>
             <p14:sldId id="260"/>
             <p14:sldId id="261"/>
@@ -157,7 +157,7 @@
             <p14:sldId id="269"/>
           </p14:sldIdLst>
         </p14:section>
-        <p14:section name="Delivery plan" id="{118a5501-73bd-2a37-d112-ed4465a52cc2}">
+        <p14:section name="Delivery plan" id="{8f77de1c-980f-d3b5-4a1a-6afc4273e9c2}">
           <p14:sldIdLst>
             <p14:sldId id="270"/>
             <p14:sldId id="271"/>
@@ -165,7 +165,7 @@
             <p14:sldId id="273"/>
           </p14:sldIdLst>
         </p14:section>
-        <p14:section name="Beyond the event" id="{7c3dac34-9642-1530-6518-94ca041afb54}">
+        <p14:section name="Beyond the event" id="{7b4a8ade-6c9b-01f9-9308-354c255b4f03}">
           <p14:sldIdLst>
             <p14:sldId id="274"/>
             <p14:sldId id="275"/>
@@ -175,7 +175,7 @@
             <p14:sldId id="279"/>
           </p14:sldIdLst>
         </p14:section>
-        <p14:section name="Roadmap and next steps" id="{879ce4f6-a3ad-54df-8554-c96f34d943c0}">
+        <p14:section name="Roadmap and next steps" id="{415e0f84-ad8d-d3d9-7cff-88d9ae792f32}">
           <p14:sldIdLst>
             <p14:sldId id="280"/>
             <p14:sldId id="281"/>
@@ -2524,7 +2524,7 @@
           <a:p>
             <a:r>
               <a:rPr lang="en-US" dirty="0"/>
-              <a:t>Play back Kevin’s answers and what we saw on the site. Class registration already runs on a home-built Experience Cloud site and in the app. The tool they want to replace is Certain. The goal is one platform for both, building on what works.</a:t>
+              <a:t>Lead with the primary ask: Certain is the one tool Kevin said they want to replace, for conferences with session management. Then the secondary goal: classes on the same platform, building on the Experience Cloud registration and app they already have.</a:t>
             </a:r>
             <a:endParaRPr lang="en-US" dirty="0"/>
           </a:p>
@@ -26758,7 +26758,7 @@
                   <a:schemeClr val="tx1"/>
                 </a:solidFill>
               </a:rPr>
-              <a:t>What we heard</a:t>
+              <a:t>Business problem</a:t>
             </a:r>
             <a:endParaRPr lang="en-US" sz="3200" dirty="0"/>
           </a:p>
@@ -26766,13 +26766,184 @@
       </p:sp>
       <p:sp>
         <p:nvSpPr>
-          <p:cNvPr id="3" name="Text 1"/>
-          <p:cNvSpPr txBox="1"/>
-          <p:nvPr/>
-        </p:nvSpPr>
-        <p:spPr>
-          <a:xfrm>
-            <a:off x="576072" y="1554480"/>
+          <p:cNvPr id="3" name="primary-ask"/>
+          <p:cNvSpPr/>
+          <p:nvPr/>
+        </p:nvSpPr>
+        <p:spPr>
+          <a:xfrm>
+            <a:off x="502920" y="1463040"/>
+            <a:ext cx="11185855" cy="1115568"/>
+          </a:xfrm>
+          <a:prstGeom prst="roundRect">
+            <a:avLst>
+              <a:gd name="adj" fmla="val 9836"/>
+            </a:avLst>
+          </a:prstGeom>
+          <a:solidFill>
+            <a:srgbClr val="000000"/>
+          </a:solidFill>
+          <a:ln w="25400">
+            <a:solidFill>
+              <a:srgbClr val="FF0068"/>
+            </a:solidFill>
+            <a:prstDash val="solid"/>
+          </a:ln>
+        </p:spPr>
+      </p:sp>
+      <p:sp>
+        <p:nvSpPr>
+          <p:cNvPr id="4" name="Text 2"/>
+          <p:cNvSpPr txBox="1"/>
+          <p:nvPr/>
+        </p:nvSpPr>
+        <p:spPr>
+          <a:xfrm>
+            <a:off x="777240" y="1591056"/>
+            <a:ext cx="3657600" cy="219456"/>
+          </a:xfrm>
+          <a:prstGeom prst="rect">
+            <a:avLst/>
+          </a:prstGeom>
+          <a:noFill/>
+          <a:ln/>
+        </p:spPr>
+        <p:txBody>
+          <a:bodyPr wrap="square" lIns="0" tIns="0" rIns="0" bIns="0" rtlCol="0" anchor="t"/>
+          <a:lstStyle/>
+          <a:p>
+            <a:pPr indent="0" marL="0">
+              <a:buNone/>
+            </a:pPr>
+            <a:r>
+              <a:rPr lang="en-US" sz="1000" b="1" spc="300" kern="0" dirty="0">
+                <a:solidFill>
+                  <a:srgbClr val="FF0068"/>
+                </a:solidFill>
+              </a:rPr>
+              <a:t>PRIMARY ASK</a:t>
+            </a:r>
+            <a:endParaRPr lang="en-US" sz="1000" dirty="0"/>
+          </a:p>
+        </p:txBody>
+      </p:sp>
+      <p:sp>
+        <p:nvSpPr>
+          <p:cNvPr id="5" name="Text 3"/>
+          <p:cNvSpPr txBox="1"/>
+          <p:nvPr/>
+        </p:nvSpPr>
+        <p:spPr>
+          <a:xfrm>
+            <a:off x="777240" y="1828800"/>
+            <a:ext cx="7498080" cy="640080"/>
+          </a:xfrm>
+          <a:prstGeom prst="rect">
+            <a:avLst/>
+          </a:prstGeom>
+          <a:noFill/>
+          <a:ln/>
+        </p:spPr>
+        <p:txBody>
+          <a:bodyPr wrap="square" lIns="0" tIns="0" rIns="0" bIns="0" rtlCol="0" anchor="ctr"/>
+          <a:lstStyle/>
+          <a:p>
+            <a:pPr indent="0" marL="0">
+              <a:buNone/>
+            </a:pPr>
+            <a:r>
+              <a:rPr lang="en-US" sz="2100" b="1" dirty="0">
+                <a:solidFill>
+                  <a:srgbClr val="FFFFFF"/>
+                </a:solidFill>
+              </a:rPr>
+              <a:t>Replace Certain with conference and session management on Salesforce</a:t>
+            </a:r>
+            <a:endParaRPr lang="en-US" sz="2100" dirty="0"/>
+          </a:p>
+        </p:txBody>
+      </p:sp>
+      <p:sp>
+        <p:nvSpPr>
+          <p:cNvPr id="6" name="Text 4"/>
+          <p:cNvSpPr txBox="1"/>
+          <p:nvPr/>
+        </p:nvSpPr>
+        <p:spPr>
+          <a:xfrm>
+            <a:off x="8321040" y="1627632"/>
+            <a:ext cx="3154680" cy="868680"/>
+          </a:xfrm>
+          <a:prstGeom prst="rect">
+            <a:avLst/>
+          </a:prstGeom>
+          <a:noFill/>
+          <a:ln/>
+        </p:spPr>
+        <p:txBody>
+          <a:bodyPr wrap="square" lIns="0" tIns="0" rIns="0" bIns="0" rtlCol="0" anchor="ctr"/>
+          <a:lstStyle/>
+          <a:p>
+            <a:pPr indent="0" marL="0">
+              <a:buNone/>
+            </a:pPr>
+            <a:r>
+              <a:rPr lang="en-US" sz="1150" dirty="0">
+                <a:solidFill>
+                  <a:srgbClr val="D9D9D9"/>
+                </a:solidFill>
+              </a:rPr>
+              <a:t>1 to 2 multi-day conferences a year, with session management, for providers, caregivers and consumers. Authorize.net today.</a:t>
+            </a:r>
+            <a:endParaRPr lang="en-US" sz="1150" dirty="0"/>
+          </a:p>
+        </p:txBody>
+      </p:sp>
+      <p:sp>
+        <p:nvSpPr>
+          <p:cNvPr id="7" name="Text 5"/>
+          <p:cNvSpPr txBox="1"/>
+          <p:nvPr/>
+        </p:nvSpPr>
+        <p:spPr>
+          <a:xfrm>
+            <a:off x="502920" y="2816352"/>
+            <a:ext cx="11185855" cy="292608"/>
+          </a:xfrm>
+          <a:prstGeom prst="rect">
+            <a:avLst/>
+          </a:prstGeom>
+          <a:noFill/>
+          <a:ln/>
+        </p:spPr>
+        <p:txBody>
+          <a:bodyPr wrap="square" lIns="0" tIns="0" rIns="0" bIns="0" rtlCol="0" anchor="t"/>
+          <a:lstStyle/>
+          <a:p>
+            <a:pPr indent="0" marL="0">
+              <a:buNone/>
+            </a:pPr>
+            <a:r>
+              <a:rPr lang="en-US" sz="1400" b="1" dirty="0">
+                <a:solidFill>
+                  <a:schemeClr val="tx1"/>
+                </a:solidFill>
+              </a:rPr>
+              <a:t>Also: run classes on the same platform, building on today’s registration instead of rebuilding it.</a:t>
+            </a:r>
+            <a:endParaRPr lang="en-US" sz="1400" dirty="0"/>
+          </a:p>
+        </p:txBody>
+      </p:sp>
+      <p:sp>
+        <p:nvSpPr>
+          <p:cNvPr id="8" name="Text 6"/>
+          <p:cNvSpPr txBox="1"/>
+          <p:nvPr/>
+        </p:nvSpPr>
+        <p:spPr>
+          <a:xfrm>
+            <a:off x="576072" y="3200400"/>
             <a:ext cx="2093976" cy="384048"/>
           </a:xfrm>
           <a:prstGeom prst="rect">
@@ -26789,26 +26960,26 @@
               <a:buNone/>
             </a:pPr>
             <a:r>
-              <a:rPr lang="en-US" sz="1500" b="1" dirty="0">
+              <a:rPr lang="en-US" sz="1400" b="1" dirty="0">
                 <a:solidFill>
                   <a:schemeClr val="tx1"/>
                 </a:solidFill>
               </a:rPr>
               <a:t>Area</a:t>
             </a:r>
-            <a:endParaRPr lang="en-US" sz="1500" dirty="0"/>
-          </a:p>
-        </p:txBody>
-      </p:sp>
-      <p:sp>
-        <p:nvSpPr>
-          <p:cNvPr id="4" name="Text 2"/>
-          <p:cNvSpPr txBox="1"/>
-          <p:nvPr/>
-        </p:nvSpPr>
-        <p:spPr>
-          <a:xfrm>
-            <a:off x="2816352" y="1554480"/>
+            <a:endParaRPr lang="en-US" sz="1400" dirty="0"/>
+          </a:p>
+        </p:txBody>
+      </p:sp>
+      <p:sp>
+        <p:nvSpPr>
+          <p:cNvPr id="9" name="Text 7"/>
+          <p:cNvSpPr txBox="1"/>
+          <p:nvPr/>
+        </p:nvSpPr>
+        <p:spPr>
+          <a:xfrm>
+            <a:off x="2816352" y="3200400"/>
             <a:ext cx="4608576" cy="384048"/>
           </a:xfrm>
           <a:prstGeom prst="rect">
@@ -26825,26 +26996,26 @@
               <a:buNone/>
             </a:pPr>
             <a:r>
-              <a:rPr lang="en-US" sz="1500" b="1" dirty="0">
+              <a:rPr lang="en-US" sz="1400" b="1" dirty="0">
                 <a:solidFill>
                   <a:schemeClr val="tx1"/>
                 </a:solidFill>
               </a:rPr>
               <a:t>Today</a:t>
             </a:r>
-            <a:endParaRPr lang="en-US" sz="1500" dirty="0"/>
-          </a:p>
-        </p:txBody>
-      </p:sp>
-      <p:sp>
-        <p:nvSpPr>
-          <p:cNvPr id="5" name="Text 3"/>
-          <p:cNvSpPr txBox="1"/>
-          <p:nvPr/>
-        </p:nvSpPr>
-        <p:spPr>
-          <a:xfrm>
-            <a:off x="7571232" y="1554480"/>
+            <a:endParaRPr lang="en-US" sz="1400" dirty="0"/>
+          </a:p>
+        </p:txBody>
+      </p:sp>
+      <p:sp>
+        <p:nvSpPr>
+          <p:cNvPr id="10" name="Text 8"/>
+          <p:cNvSpPr txBox="1"/>
+          <p:nvPr/>
+        </p:nvSpPr>
+        <p:spPr>
+          <a:xfrm>
+            <a:off x="7571232" y="3200400"/>
             <a:ext cx="4041648" cy="384048"/>
           </a:xfrm>
           <a:prstGeom prst="rect">
@@ -26861,26 +27032,26 @@
               <a:buNone/>
             </a:pPr>
             <a:r>
-              <a:rPr lang="en-US" sz="1500" b="1" dirty="0">
+              <a:rPr lang="en-US" sz="1400" b="1" dirty="0">
                 <a:solidFill>
                   <a:schemeClr val="tx1"/>
                 </a:solidFill>
               </a:rPr>
               <a:t>Where we take it</a:t>
             </a:r>
-            <a:endParaRPr lang="en-US" sz="1500" dirty="0"/>
-          </a:p>
-        </p:txBody>
-      </p:sp>
-      <p:sp>
-        <p:nvSpPr>
-          <p:cNvPr id="6" name="Shape 4"/>
+            <a:endParaRPr lang="en-US" sz="1400" dirty="0"/>
+          </a:p>
+        </p:txBody>
+      </p:sp>
+      <p:sp>
+        <p:nvSpPr>
+          <p:cNvPr id="11" name="Shape 9"/>
           <p:cNvSpPr/>
           <p:nvPr/>
         </p:nvSpPr>
         <p:spPr>
           <a:xfrm>
-            <a:off x="502920" y="2011680"/>
+            <a:off x="502920" y="3657600"/>
             <a:ext cx="11183112" cy="0"/>
           </a:xfrm>
           <a:prstGeom prst="line">
@@ -26897,14 +27068,14 @@
       </p:sp>
       <p:sp>
         <p:nvSpPr>
-          <p:cNvPr id="7" name="Text 5"/>
-          <p:cNvSpPr txBox="1"/>
-          <p:nvPr/>
-        </p:nvSpPr>
-        <p:spPr>
-          <a:xfrm>
-            <a:off x="576072" y="2084832"/>
-            <a:ext cx="2093976" cy="530352"/>
+          <p:cNvPr id="12" name="Text 10"/>
+          <p:cNvSpPr txBox="1"/>
+          <p:nvPr/>
+        </p:nvSpPr>
+        <p:spPr>
+          <a:xfrm>
+            <a:off x="576072" y="3730752"/>
+            <a:ext cx="2093976" cy="457200"/>
           </a:xfrm>
           <a:prstGeom prst="rect">
             <a:avLst/>
@@ -26920,27 +27091,27 @@
               <a:buNone/>
             </a:pPr>
             <a:r>
-              <a:rPr lang="en-US" sz="1300" b="1" dirty="0">
+              <a:rPr lang="en-US" sz="1250" b="1" dirty="0">
                 <a:solidFill>
                   <a:schemeClr val="tx1"/>
                 </a:solidFill>
               </a:rPr>
-              <a:t>Classes and events</a:t>
-            </a:r>
-            <a:endParaRPr lang="en-US" sz="1300" dirty="0"/>
-          </a:p>
-        </p:txBody>
-      </p:sp>
-      <p:sp>
-        <p:nvSpPr>
-          <p:cNvPr id="8" name="Text 6"/>
-          <p:cNvSpPr txBox="1"/>
-          <p:nvPr/>
-        </p:nvSpPr>
-        <p:spPr>
-          <a:xfrm>
-            <a:off x="2816352" y="2084832"/>
-            <a:ext cx="4608576" cy="530352"/>
+              <a:t>Conferences</a:t>
+            </a:r>
+            <a:endParaRPr lang="en-US" sz="1250" dirty="0"/>
+          </a:p>
+        </p:txBody>
+      </p:sp>
+      <p:sp>
+        <p:nvSpPr>
+          <p:cNvPr id="13" name="Text 11"/>
+          <p:cNvSpPr txBox="1"/>
+          <p:nvPr/>
+        </p:nvSpPr>
+        <p:spPr>
+          <a:xfrm>
+            <a:off x="2816352" y="3730752"/>
+            <a:ext cx="4608576" cy="457200"/>
           </a:xfrm>
           <a:prstGeom prst="rect">
             <a:avLst/>
@@ -26956,27 +27127,27 @@
               <a:buNone/>
             </a:pPr>
             <a:r>
-              <a:rPr lang="en-US" sz="1300" dirty="0">
+              <a:rPr lang="en-US" sz="1250" dirty="0">
                 <a:solidFill>
                   <a:srgbClr val="4D4D4D"/>
                 </a:solidFill>
               </a:rPr>
-              <a:t>Sitecore listings open a home-built Experience Cloud site; Chase payments; confirmation up to 24 hours</a:t>
-            </a:r>
-            <a:endParaRPr lang="en-US" sz="1300" dirty="0"/>
-          </a:p>
-        </p:txBody>
-      </p:sp>
-      <p:sp>
-        <p:nvSpPr>
-          <p:cNvPr id="9" name="Text 7"/>
-          <p:cNvSpPr txBox="1"/>
-          <p:nvPr/>
-        </p:nvSpPr>
-        <p:spPr>
-          <a:xfrm>
-            <a:off x="7571232" y="2084832"/>
-            <a:ext cx="4041648" cy="530352"/>
+              <a:t>Certain for multi-day events; Authorize.net payments</a:t>
+            </a:r>
+            <a:endParaRPr lang="en-US" sz="1250" dirty="0"/>
+          </a:p>
+        </p:txBody>
+      </p:sp>
+      <p:sp>
+        <p:nvSpPr>
+          <p:cNvPr id="14" name="Text 12"/>
+          <p:cNvSpPr txBox="1"/>
+          <p:nvPr/>
+        </p:nvSpPr>
+        <p:spPr>
+          <a:xfrm>
+            <a:off x="7571232" y="3730752"/>
+            <a:ext cx="4041648" cy="457200"/>
           </a:xfrm>
           <a:prstGeom prst="rect">
             <a:avLst/>
@@ -26992,26 +27163,26 @@
               <a:buNone/>
             </a:pPr>
             <a:r>
-              <a:rPr lang="en-US" sz="1300" dirty="0">
+              <a:rPr lang="en-US" sz="1250" dirty="0">
                 <a:solidFill>
                   <a:srgbClr val="4D4D4D"/>
                 </a:solidFill>
               </a:rPr>
-              <a:t>Keep the site and improve it on one shared event model</a:t>
-            </a:r>
-            <a:endParaRPr lang="en-US" sz="1300" dirty="0"/>
-          </a:p>
-        </p:txBody>
-      </p:sp>
-      <p:sp>
-        <p:nvSpPr>
-          <p:cNvPr id="10" name="Shape 8"/>
+              <a:t>Replace with Salesforce conference and session management</a:t>
+            </a:r>
+            <a:endParaRPr lang="en-US" sz="1250" dirty="0"/>
+          </a:p>
+        </p:txBody>
+      </p:sp>
+      <p:sp>
+        <p:nvSpPr>
+          <p:cNvPr id="15" name="Shape 13"/>
           <p:cNvSpPr/>
           <p:nvPr/>
         </p:nvSpPr>
         <p:spPr>
           <a:xfrm>
-            <a:off x="502920" y="2651760"/>
+            <a:off x="502920" y="4224528"/>
             <a:ext cx="11183112" cy="0"/>
           </a:xfrm>
           <a:prstGeom prst="line">
@@ -27028,14 +27199,14 @@
       </p:sp>
       <p:sp>
         <p:nvSpPr>
-          <p:cNvPr id="11" name="Text 9"/>
-          <p:cNvSpPr txBox="1"/>
-          <p:nvPr/>
-        </p:nvSpPr>
-        <p:spPr>
-          <a:xfrm>
-            <a:off x="576072" y="2724912"/>
-            <a:ext cx="2093976" cy="530352"/>
+          <p:cNvPr id="16" name="Text 14"/>
+          <p:cNvSpPr txBox="1"/>
+          <p:nvPr/>
+        </p:nvSpPr>
+        <p:spPr>
+          <a:xfrm>
+            <a:off x="576072" y="4297680"/>
+            <a:ext cx="2093976" cy="457200"/>
           </a:xfrm>
           <a:prstGeom prst="rect">
             <a:avLst/>
@@ -27051,27 +27222,27 @@
               <a:buNone/>
             </a:pPr>
             <a:r>
-              <a:rPr lang="en-US" sz="1300" b="1" dirty="0">
+              <a:rPr lang="en-US" sz="1250" b="1" dirty="0">
                 <a:solidFill>
                   <a:schemeClr val="tx1"/>
                 </a:solidFill>
               </a:rPr>
-              <a:t>Mobile app</a:t>
-            </a:r>
-            <a:endParaRPr lang="en-US" sz="1300" dirty="0"/>
-          </a:p>
-        </p:txBody>
-      </p:sp>
-      <p:sp>
-        <p:nvSpPr>
-          <p:cNvPr id="12" name="Text 10"/>
-          <p:cNvSpPr txBox="1"/>
-          <p:nvPr/>
-        </p:nvSpPr>
-        <p:spPr>
-          <a:xfrm>
-            <a:off x="2816352" y="2724912"/>
-            <a:ext cx="4608576" cy="530352"/>
+              <a:t>Classes and events</a:t>
+            </a:r>
+            <a:endParaRPr lang="en-US" sz="1250" dirty="0"/>
+          </a:p>
+        </p:txBody>
+      </p:sp>
+      <p:sp>
+        <p:nvSpPr>
+          <p:cNvPr id="17" name="Text 15"/>
+          <p:cNvSpPr txBox="1"/>
+          <p:nvPr/>
+        </p:nvSpPr>
+        <p:spPr>
+          <a:xfrm>
+            <a:off x="2816352" y="4297680"/>
+            <a:ext cx="4608576" cy="457200"/>
           </a:xfrm>
           <a:prstGeom prst="rect">
             <a:avLst/>
@@ -27087,27 +27258,27 @@
               <a:buNone/>
             </a:pPr>
             <a:r>
-              <a:rPr lang="en-US" sz="1300" dirty="0">
+              <a:rPr lang="en-US" sz="1250" dirty="0">
                 <a:solidFill>
                   <a:srgbClr val="4D4D4D"/>
                 </a:solidFill>
               </a:rPr>
-              <a:t>People can already register for events in the app</a:t>
-            </a:r>
-            <a:endParaRPr lang="en-US" sz="1300" dirty="0"/>
-          </a:p>
-        </p:txBody>
-      </p:sp>
-      <p:sp>
-        <p:nvSpPr>
-          <p:cNvPr id="13" name="Text 11"/>
-          <p:cNvSpPr txBox="1"/>
-          <p:nvPr/>
-        </p:nvSpPr>
-        <p:spPr>
-          <a:xfrm>
-            <a:off x="7571232" y="2724912"/>
-            <a:ext cx="4041648" cy="530352"/>
+              <a:t>Sitecore listings open a home-built Experience Cloud site; Chase payments; confirmation up to 24 hours</a:t>
+            </a:r>
+            <a:endParaRPr lang="en-US" sz="1250" dirty="0"/>
+          </a:p>
+        </p:txBody>
+      </p:sp>
+      <p:sp>
+        <p:nvSpPr>
+          <p:cNvPr id="18" name="Text 16"/>
+          <p:cNvSpPr txBox="1"/>
+          <p:nvPr/>
+        </p:nvSpPr>
+        <p:spPr>
+          <a:xfrm>
+            <a:off x="7571232" y="4297680"/>
+            <a:ext cx="4041648" cy="457200"/>
           </a:xfrm>
           <a:prstGeom prst="rect">
             <a:avLst/>
@@ -27123,26 +27294,26 @@
               <a:buNone/>
             </a:pPr>
             <a:r>
-              <a:rPr lang="en-US" sz="1300" dirty="0">
+              <a:rPr lang="en-US" sz="1250" dirty="0">
                 <a:solidFill>
                   <a:srgbClr val="4D4D4D"/>
                 </a:solidFill>
               </a:rPr>
-              <a:t>Keep it, connected to the same event model</a:t>
-            </a:r>
-            <a:endParaRPr lang="en-US" sz="1300" dirty="0"/>
-          </a:p>
-        </p:txBody>
-      </p:sp>
-      <p:sp>
-        <p:nvSpPr>
-          <p:cNvPr id="14" name="Shape 12"/>
+              <a:t>Keep the site and improve it on one shared event model</a:t>
+            </a:r>
+            <a:endParaRPr lang="en-US" sz="1250" dirty="0"/>
+          </a:p>
+        </p:txBody>
+      </p:sp>
+      <p:sp>
+        <p:nvSpPr>
+          <p:cNvPr id="19" name="Shape 17"/>
           <p:cNvSpPr/>
           <p:nvPr/>
         </p:nvSpPr>
         <p:spPr>
           <a:xfrm>
-            <a:off x="502920" y="3291840"/>
+            <a:off x="502920" y="4791456"/>
             <a:ext cx="11183112" cy="0"/>
           </a:xfrm>
           <a:prstGeom prst="line">
@@ -27159,14 +27330,14 @@
       </p:sp>
       <p:sp>
         <p:nvSpPr>
-          <p:cNvPr id="15" name="Text 13"/>
-          <p:cNvSpPr txBox="1"/>
-          <p:nvPr/>
-        </p:nvSpPr>
-        <p:spPr>
-          <a:xfrm>
-            <a:off x="576072" y="3364992"/>
-            <a:ext cx="2093976" cy="530352"/>
+          <p:cNvPr id="20" name="Text 18"/>
+          <p:cNvSpPr txBox="1"/>
+          <p:nvPr/>
+        </p:nvSpPr>
+        <p:spPr>
+          <a:xfrm>
+            <a:off x="576072" y="4864608"/>
+            <a:ext cx="2093976" cy="457200"/>
           </a:xfrm>
           <a:prstGeom prst="rect">
             <a:avLst/>
@@ -27182,27 +27353,27 @@
               <a:buNone/>
             </a:pPr>
             <a:r>
-              <a:rPr lang="en-US" sz="1300" b="1" dirty="0">
+              <a:rPr lang="en-US" sz="1250" b="1" dirty="0">
                 <a:solidFill>
                   <a:schemeClr val="tx1"/>
                 </a:solidFill>
               </a:rPr>
-              <a:t>Conferences</a:t>
-            </a:r>
-            <a:endParaRPr lang="en-US" sz="1300" dirty="0"/>
-          </a:p>
-        </p:txBody>
-      </p:sp>
-      <p:sp>
-        <p:nvSpPr>
-          <p:cNvPr id="16" name="Text 14"/>
-          <p:cNvSpPr txBox="1"/>
-          <p:nvPr/>
-        </p:nvSpPr>
-        <p:spPr>
-          <a:xfrm>
-            <a:off x="2816352" y="3364992"/>
-            <a:ext cx="4608576" cy="530352"/>
+              <a:t>Mobile app</a:t>
+            </a:r>
+            <a:endParaRPr lang="en-US" sz="1250" dirty="0"/>
+          </a:p>
+        </p:txBody>
+      </p:sp>
+      <p:sp>
+        <p:nvSpPr>
+          <p:cNvPr id="21" name="Text 19"/>
+          <p:cNvSpPr txBox="1"/>
+          <p:nvPr/>
+        </p:nvSpPr>
+        <p:spPr>
+          <a:xfrm>
+            <a:off x="2816352" y="4864608"/>
+            <a:ext cx="4608576" cy="457200"/>
           </a:xfrm>
           <a:prstGeom prst="rect">
             <a:avLst/>
@@ -27218,27 +27389,27 @@
               <a:buNone/>
             </a:pPr>
             <a:r>
-              <a:rPr lang="en-US" sz="1300" dirty="0">
+              <a:rPr lang="en-US" sz="1250" dirty="0">
                 <a:solidFill>
                   <a:srgbClr val="4D4D4D"/>
                 </a:solidFill>
               </a:rPr>
-              <a:t>Certain for 1 to 2 multi-day events a year; Authorize.net</a:t>
-            </a:r>
-            <a:endParaRPr lang="en-US" sz="1300" dirty="0"/>
-          </a:p>
-        </p:txBody>
-      </p:sp>
-      <p:sp>
-        <p:nvSpPr>
-          <p:cNvPr id="17" name="Text 15"/>
-          <p:cNvSpPr txBox="1"/>
-          <p:nvPr/>
-        </p:nvSpPr>
-        <p:spPr>
-          <a:xfrm>
-            <a:off x="7571232" y="3364992"/>
-            <a:ext cx="4041648" cy="530352"/>
+              <a:t>People can already register for events in the app</a:t>
+            </a:r>
+            <a:endParaRPr lang="en-US" sz="1250" dirty="0"/>
+          </a:p>
+        </p:txBody>
+      </p:sp>
+      <p:sp>
+        <p:nvSpPr>
+          <p:cNvPr id="22" name="Text 20"/>
+          <p:cNvSpPr txBox="1"/>
+          <p:nvPr/>
+        </p:nvSpPr>
+        <p:spPr>
+          <a:xfrm>
+            <a:off x="7571232" y="4864608"/>
+            <a:ext cx="4041648" cy="457200"/>
           </a:xfrm>
           <a:prstGeom prst="rect">
             <a:avLst/>
@@ -27254,26 +27425,26 @@
               <a:buNone/>
             </a:pPr>
             <a:r>
-              <a:rPr lang="en-US" sz="1300" dirty="0">
+              <a:rPr lang="en-US" sz="1250" dirty="0">
                 <a:solidFill>
                   <a:srgbClr val="4D4D4D"/>
                 </a:solidFill>
               </a:rPr>
-              <a:t>Replace with Salesforce conference and session management</a:t>
-            </a:r>
-            <a:endParaRPr lang="en-US" sz="1300" dirty="0"/>
-          </a:p>
-        </p:txBody>
-      </p:sp>
-      <p:sp>
-        <p:nvSpPr>
-          <p:cNvPr id="18" name="Shape 16"/>
+              <a:t>Keep it, connected to the same event model</a:t>
+            </a:r>
+            <a:endParaRPr lang="en-US" sz="1250" dirty="0"/>
+          </a:p>
+        </p:txBody>
+      </p:sp>
+      <p:sp>
+        <p:nvSpPr>
+          <p:cNvPr id="23" name="Shape 21"/>
           <p:cNvSpPr/>
           <p:nvPr/>
         </p:nvSpPr>
         <p:spPr>
           <a:xfrm>
-            <a:off x="502920" y="3931920"/>
+            <a:off x="502920" y="5358384"/>
             <a:ext cx="11183112" cy="0"/>
           </a:xfrm>
           <a:prstGeom prst="line">
@@ -27290,14 +27461,14 @@
       </p:sp>
       <p:sp>
         <p:nvSpPr>
-          <p:cNvPr id="19" name="Text 17"/>
-          <p:cNvSpPr txBox="1"/>
-          <p:nvPr/>
-        </p:nvSpPr>
-        <p:spPr>
-          <a:xfrm>
-            <a:off x="576072" y="4005072"/>
-            <a:ext cx="2093976" cy="530352"/>
+          <p:cNvPr id="24" name="Text 22"/>
+          <p:cNvSpPr txBox="1"/>
+          <p:nvPr/>
+        </p:nvSpPr>
+        <p:spPr>
+          <a:xfrm>
+            <a:off x="576072" y="5431536"/>
+            <a:ext cx="2093976" cy="457200"/>
           </a:xfrm>
           <a:prstGeom prst="rect">
             <a:avLst/>
@@ -27313,27 +27484,27 @@
               <a:buNone/>
             </a:pPr>
             <a:r>
-              <a:rPr lang="en-US" sz="1300" b="1" dirty="0">
+              <a:rPr lang="en-US" sz="1250" b="1" dirty="0">
                 <a:solidFill>
                   <a:schemeClr val="tx1"/>
                 </a:solidFill>
               </a:rPr>
-              <a:t>Who registers</a:t>
-            </a:r>
-            <a:endParaRPr lang="en-US" sz="1300" dirty="0"/>
-          </a:p>
-        </p:txBody>
-      </p:sp>
-      <p:sp>
-        <p:nvSpPr>
-          <p:cNvPr id="20" name="Text 18"/>
-          <p:cNvSpPr txBox="1"/>
-          <p:nvPr/>
-        </p:nvSpPr>
-        <p:spPr>
-          <a:xfrm>
-            <a:off x="2816352" y="4005072"/>
-            <a:ext cx="4608576" cy="530352"/>
+              <a:t>Platform</a:t>
+            </a:r>
+            <a:endParaRPr lang="en-US" sz="1250" dirty="0"/>
+          </a:p>
+        </p:txBody>
+      </p:sp>
+      <p:sp>
+        <p:nvSpPr>
+          <p:cNvPr id="25" name="Text 23"/>
+          <p:cNvSpPr txBox="1"/>
+          <p:nvPr/>
+        </p:nvSpPr>
+        <p:spPr>
+          <a:xfrm>
+            <a:off x="2816352" y="5431536"/>
+            <a:ext cx="4608576" cy="457200"/>
           </a:xfrm>
           <a:prstGeom prst="rect">
             <a:avLst/>
@@ -27349,27 +27520,27 @@
               <a:buNone/>
             </a:pPr>
             <a:r>
-              <a:rPr lang="en-US" sz="1300" dirty="0">
+              <a:rPr lang="en-US" sz="1250" dirty="0">
                 <a:solidFill>
                   <a:srgbClr val="4D4D4D"/>
                 </a:solidFill>
               </a:rPr>
-              <a:t>Consumers, caregivers and providers</a:t>
-            </a:r>
-            <a:endParaRPr lang="en-US" sz="1300" dirty="0"/>
-          </a:p>
-        </p:txBody>
-      </p:sp>
-      <p:sp>
-        <p:nvSpPr>
-          <p:cNvPr id="21" name="Text 19"/>
-          <p:cNvSpPr txBox="1"/>
-          <p:nvPr/>
-        </p:nvSpPr>
-        <p:spPr>
-          <a:xfrm>
-            <a:off x="7571232" y="4005072"/>
-            <a:ext cx="4041648" cy="530352"/>
+              <a:t>Health Cloud and Marketing Cloud; Epic not needed</a:t>
+            </a:r>
+            <a:endParaRPr lang="en-US" sz="1250" dirty="0"/>
+          </a:p>
+        </p:txBody>
+      </p:sp>
+      <p:sp>
+        <p:nvSpPr>
+          <p:cNvPr id="26" name="Text 24"/>
+          <p:cNvSpPr txBox="1"/>
+          <p:nvPr/>
+        </p:nvSpPr>
+        <p:spPr>
+          <a:xfrm>
+            <a:off x="7571232" y="5431536"/>
+            <a:ext cx="4041648" cy="457200"/>
           </a:xfrm>
           <a:prstGeom prst="rect">
             <a:avLst/>
@@ -27385,26 +27556,26 @@
               <a:buNone/>
             </a:pPr>
             <a:r>
-              <a:rPr lang="en-US" sz="1300" dirty="0">
+              <a:rPr lang="en-US" sz="1250" dirty="0">
                 <a:solidFill>
                   <a:srgbClr val="4D4D4D"/>
                 </a:solidFill>
               </a:rPr>
-              <a:t>One profile per person, matched to Health Cloud</a:t>
-            </a:r>
-            <a:endParaRPr lang="en-US" sz="1300" dirty="0"/>
-          </a:p>
-        </p:txBody>
-      </p:sp>
-      <p:sp>
-        <p:nvSpPr>
-          <p:cNvPr id="22" name="Shape 20"/>
+              <a:t>Built on what Memorial Hermann already owns</a:t>
+            </a:r>
+            <a:endParaRPr lang="en-US" sz="1250" dirty="0"/>
+          </a:p>
+        </p:txBody>
+      </p:sp>
+      <p:sp>
+        <p:nvSpPr>
+          <p:cNvPr id="27" name="Shape 25"/>
           <p:cNvSpPr/>
           <p:nvPr/>
         </p:nvSpPr>
         <p:spPr>
           <a:xfrm>
-            <a:off x="502920" y="4572000"/>
+            <a:off x="502920" y="5925312"/>
             <a:ext cx="11183112" cy="0"/>
           </a:xfrm>
           <a:prstGeom prst="line">
@@ -27418,173 +27589,6 @@
             <a:prstDash val="sysDot"/>
           </a:ln>
         </p:spPr>
-      </p:sp>
-      <p:sp>
-        <p:nvSpPr>
-          <p:cNvPr id="23" name="Text 21"/>
-          <p:cNvSpPr txBox="1"/>
-          <p:nvPr/>
-        </p:nvSpPr>
-        <p:spPr>
-          <a:xfrm>
-            <a:off x="576072" y="4645152"/>
-            <a:ext cx="2093976" cy="530352"/>
-          </a:xfrm>
-          <a:prstGeom prst="rect">
-            <a:avLst/>
-          </a:prstGeom>
-          <a:noFill/>
-          <a:ln/>
-        </p:spPr>
-        <p:txBody>
-          <a:bodyPr wrap="square" lIns="0" tIns="0" rIns="0" bIns="0" rtlCol="0" anchor="ctr"/>
-          <a:lstStyle/>
-          <a:p>
-            <a:pPr indent="0" marL="0">
-              <a:buNone/>
-            </a:pPr>
-            <a:r>
-              <a:rPr lang="en-US" sz="1300" b="1" dirty="0">
-                <a:solidFill>
-                  <a:schemeClr val="tx1"/>
-                </a:solidFill>
-              </a:rPr>
-              <a:t>Platform</a:t>
-            </a:r>
-            <a:endParaRPr lang="en-US" sz="1300" dirty="0"/>
-          </a:p>
-        </p:txBody>
-      </p:sp>
-      <p:sp>
-        <p:nvSpPr>
-          <p:cNvPr id="24" name="Text 22"/>
-          <p:cNvSpPr txBox="1"/>
-          <p:nvPr/>
-        </p:nvSpPr>
-        <p:spPr>
-          <a:xfrm>
-            <a:off x="2816352" y="4645152"/>
-            <a:ext cx="4608576" cy="530352"/>
-          </a:xfrm>
-          <a:prstGeom prst="rect">
-            <a:avLst/>
-          </a:prstGeom>
-          <a:noFill/>
-          <a:ln/>
-        </p:spPr>
-        <p:txBody>
-          <a:bodyPr wrap="square" lIns="0" tIns="0" rIns="0" bIns="0" rtlCol="0" anchor="ctr"/>
-          <a:lstStyle/>
-          <a:p>
-            <a:pPr indent="0" marL="0">
-              <a:buNone/>
-            </a:pPr>
-            <a:r>
-              <a:rPr lang="en-US" sz="1300" dirty="0">
-                <a:solidFill>
-                  <a:srgbClr val="4D4D4D"/>
-                </a:solidFill>
-              </a:rPr>
-              <a:t>Health Cloud and Marketing Cloud; Epic not needed</a:t>
-            </a:r>
-            <a:endParaRPr lang="en-US" sz="1300" dirty="0"/>
-          </a:p>
-        </p:txBody>
-      </p:sp>
-      <p:sp>
-        <p:nvSpPr>
-          <p:cNvPr id="25" name="Text 23"/>
-          <p:cNvSpPr txBox="1"/>
-          <p:nvPr/>
-        </p:nvSpPr>
-        <p:spPr>
-          <a:xfrm>
-            <a:off x="7571232" y="4645152"/>
-            <a:ext cx="4041648" cy="530352"/>
-          </a:xfrm>
-          <a:prstGeom prst="rect">
-            <a:avLst/>
-          </a:prstGeom>
-          <a:noFill/>
-          <a:ln/>
-        </p:spPr>
-        <p:txBody>
-          <a:bodyPr wrap="square" lIns="0" tIns="0" rIns="0" bIns="0" rtlCol="0" anchor="ctr"/>
-          <a:lstStyle/>
-          <a:p>
-            <a:pPr indent="0" marL="0">
-              <a:buNone/>
-            </a:pPr>
-            <a:r>
-              <a:rPr lang="en-US" sz="1300" dirty="0">
-                <a:solidFill>
-                  <a:srgbClr val="4D4D4D"/>
-                </a:solidFill>
-              </a:rPr>
-              <a:t>Built on what Memorial Hermann already owns</a:t>
-            </a:r>
-            <a:endParaRPr lang="en-US" sz="1300" dirty="0"/>
-          </a:p>
-        </p:txBody>
-      </p:sp>
-      <p:sp>
-        <p:nvSpPr>
-          <p:cNvPr id="26" name="Shape 24"/>
-          <p:cNvSpPr/>
-          <p:nvPr/>
-        </p:nvSpPr>
-        <p:spPr>
-          <a:xfrm>
-            <a:off x="502920" y="5212080"/>
-            <a:ext cx="11183112" cy="0"/>
-          </a:xfrm>
-          <a:prstGeom prst="line">
-            <a:avLst/>
-          </a:prstGeom>
-          <a:noFill/>
-          <a:ln w="9525">
-            <a:solidFill>
-              <a:srgbClr val="8C8C8C"/>
-            </a:solidFill>
-            <a:prstDash val="sysDot"/>
-          </a:ln>
-        </p:spPr>
-      </p:sp>
-      <p:sp>
-        <p:nvSpPr>
-          <p:cNvPr id="27" name="Text 25"/>
-          <p:cNvSpPr txBox="1"/>
-          <p:nvPr/>
-        </p:nvSpPr>
-        <p:spPr>
-          <a:xfrm>
-            <a:off x="502920" y="5669280"/>
-            <a:ext cx="11185855" cy="411480"/>
-          </a:xfrm>
-          <a:prstGeom prst="rect">
-            <a:avLst/>
-          </a:prstGeom>
-          <a:noFill/>
-          <a:ln/>
-        </p:spPr>
-        <p:txBody>
-          <a:bodyPr wrap="square" lIns="0" tIns="0" rIns="0" bIns="0" rtlCol="0" anchor="t"/>
-          <a:lstStyle/>
-          <a:p>
-            <a:pPr indent="0" marL="0">
-              <a:buNone/>
-            </a:pPr>
-            <a:r>
-              <a:rPr lang="en-US" sz="1500" b="1" dirty="0">
-                <a:solidFill>
-                  <a:schemeClr val="tx1"/>
-                </a:solidFill>
-              </a:rPr>
-              <a:t>The ask: replace Certain and run classes and conferences on one Salesforce platform, without rebuilding what already works.</a:t>
-            </a:r>
-            <a:endParaRPr lang="en-US" sz="1500" dirty="0"/>
-          </a:p>
-        </p:txBody>
       </p:sp>
       <p:sp>
         <p:nvSpPr>

</xml_diff>